<commit_message>
update Question of throughput in tut2
</commit_message>
<xml_diff>
--- a/tutorial/T02/tut02.pptx
+++ b/tutorial/T02/tut02.pptx
@@ -2342,7 +2342,7 @@
           <a:p>
             <a:fld id="{E03FF167-5468-407F-BF08-399F401F3E28}" type="datetimeFigureOut">
               <a:rPr lang="en-HK" smtClean="0"/>
-              <a:t>16/1/2025</a:t>
+              <a:t>8/5/2025</a:t>
             </a:fld>
             <a:endParaRPr lang="en-HK"/>
           </a:p>
@@ -4593,7 +4593,7 @@
           <a:p>
             <a:fld id="{2425905D-C0C4-D040-B3F5-79CCA23FA4EB}" type="datetimeFigureOut">
               <a:rPr lang="en-US" smtClean="0"/>
-              <a:t>1/16/2025</a:t>
+              <a:t>5/8/2025</a:t>
             </a:fld>
             <a:endParaRPr lang="en-US"/>
           </a:p>
@@ -4793,7 +4793,7 @@
           <a:p>
             <a:fld id="{2425905D-C0C4-D040-B3F5-79CCA23FA4EB}" type="datetimeFigureOut">
               <a:rPr lang="en-US" smtClean="0"/>
-              <a:t>1/16/2025</a:t>
+              <a:t>5/8/2025</a:t>
             </a:fld>
             <a:endParaRPr lang="en-US"/>
           </a:p>
@@ -5003,7 +5003,7 @@
           <a:p>
             <a:fld id="{2425905D-C0C4-D040-B3F5-79CCA23FA4EB}" type="datetimeFigureOut">
               <a:rPr lang="en-US" smtClean="0"/>
-              <a:t>1/16/2025</a:t>
+              <a:t>5/8/2025</a:t>
             </a:fld>
             <a:endParaRPr lang="en-US"/>
           </a:p>
@@ -5203,7 +5203,7 @@
           <a:p>
             <a:fld id="{2425905D-C0C4-D040-B3F5-79CCA23FA4EB}" type="datetimeFigureOut">
               <a:rPr lang="en-US" smtClean="0"/>
-              <a:t>1/16/2025</a:t>
+              <a:t>5/8/2025</a:t>
             </a:fld>
             <a:endParaRPr lang="en-US"/>
           </a:p>
@@ -5479,7 +5479,7 @@
           <a:p>
             <a:fld id="{2425905D-C0C4-D040-B3F5-79CCA23FA4EB}" type="datetimeFigureOut">
               <a:rPr lang="en-US" smtClean="0"/>
-              <a:t>1/16/2025</a:t>
+              <a:t>5/8/2025</a:t>
             </a:fld>
             <a:endParaRPr lang="en-US"/>
           </a:p>
@@ -5747,7 +5747,7 @@
           <a:p>
             <a:fld id="{2425905D-C0C4-D040-B3F5-79CCA23FA4EB}" type="datetimeFigureOut">
               <a:rPr lang="en-US" smtClean="0"/>
-              <a:t>1/16/2025</a:t>
+              <a:t>5/8/2025</a:t>
             </a:fld>
             <a:endParaRPr lang="en-US"/>
           </a:p>
@@ -6162,7 +6162,7 @@
           <a:p>
             <a:fld id="{2425905D-C0C4-D040-B3F5-79CCA23FA4EB}" type="datetimeFigureOut">
               <a:rPr lang="en-US" smtClean="0"/>
-              <a:t>1/16/2025</a:t>
+              <a:t>5/8/2025</a:t>
             </a:fld>
             <a:endParaRPr lang="en-US"/>
           </a:p>
@@ -6304,7 +6304,7 @@
           <a:p>
             <a:fld id="{2425905D-C0C4-D040-B3F5-79CCA23FA4EB}" type="datetimeFigureOut">
               <a:rPr lang="en-US" smtClean="0"/>
-              <a:t>1/16/2025</a:t>
+              <a:t>5/8/2025</a:t>
             </a:fld>
             <a:endParaRPr lang="en-US"/>
           </a:p>
@@ -6417,7 +6417,7 @@
           <a:p>
             <a:fld id="{2425905D-C0C4-D040-B3F5-79CCA23FA4EB}" type="datetimeFigureOut">
               <a:rPr lang="en-US" smtClean="0"/>
-              <a:t>1/16/2025</a:t>
+              <a:t>5/8/2025</a:t>
             </a:fld>
             <a:endParaRPr lang="en-US"/>
           </a:p>
@@ -6730,7 +6730,7 @@
           <a:p>
             <a:fld id="{2425905D-C0C4-D040-B3F5-79CCA23FA4EB}" type="datetimeFigureOut">
               <a:rPr lang="en-US" smtClean="0"/>
-              <a:t>1/16/2025</a:t>
+              <a:t>5/8/2025</a:t>
             </a:fld>
             <a:endParaRPr lang="en-US"/>
           </a:p>
@@ -7019,7 +7019,7 @@
           <a:p>
             <a:fld id="{2425905D-C0C4-D040-B3F5-79CCA23FA4EB}" type="datetimeFigureOut">
               <a:rPr lang="en-US" smtClean="0"/>
-              <a:t>1/16/2025</a:t>
+              <a:t>5/8/2025</a:t>
             </a:fld>
             <a:endParaRPr lang="en-US"/>
           </a:p>
@@ -7262,7 +7262,7 @@
           <a:p>
             <a:fld id="{2425905D-C0C4-D040-B3F5-79CCA23FA4EB}" type="datetimeFigureOut">
               <a:rPr lang="en-US" smtClean="0"/>
-              <a:t>1/16/2025</a:t>
+              <a:t>5/8/2025</a:t>
             </a:fld>
             <a:endParaRPr lang="en-US"/>
           </a:p>
@@ -10710,8 +10710,29 @@
                   <a:srgbClr val="FF0000"/>
                 </a:solidFill>
               </a:rPr>
-              <a:t>Throughput = 25MB * 8 / (2s + 1.28333s) = 60.9 Mbps </a:t>
-            </a:r>
+              <a:t>Throughput = 25MB * 8 / 4.5666 =43</a:t>
+            </a:r>
+            <a:r>
+              <a:rPr lang="en-HK" sz="2400">
+                <a:solidFill>
+                  <a:srgbClr val="FF0000"/>
+                </a:solidFill>
+              </a:rPr>
+              <a:t>.8 </a:t>
+            </a:r>
+            <a:r>
+              <a:rPr lang="en-US" sz="2400">
+                <a:solidFill>
+                  <a:srgbClr val="FF0000"/>
+                </a:solidFill>
+              </a:rPr>
+              <a:t>Mbps </a:t>
+            </a:r>
+            <a:endParaRPr lang="en-US" sz="2400" dirty="0">
+              <a:solidFill>
+                <a:srgbClr val="FF0000"/>
+              </a:solidFill>
+            </a:endParaRPr>
           </a:p>
         </p:txBody>
       </p:sp>

</xml_diff>